<commit_message>
Correct the student surname in the submitted documents
Co-Authored-By: Claude Opus 4.8 (1M context) <noreply@anthropic.com>
</commit_message>
<xml_diff>
--- a/deliverables/ไฟล์นำเสนอ.pptx
+++ b/deliverables/ไฟล์นำเสนอ.pptx
@@ -3185,7 +3185,7 @@
                 <a:cs typeface="Leelawadee UI"/>
                 <a:ea typeface="Leelawadee UI"/>
               </a:rPr>
-              <a:t>https://yumpakjure.onrender.com/&lt;br/&gt;สุภวัฒน์ จันไพิตร | 671320101</a:t>
+              <a:t>https://yumpakjure.onrender.com/&lt;br/&gt;สุภวัฒน์ จันไพจิตร | 671320101</a:t>
             </a:r>
           </a:p>
         </p:txBody>
@@ -4326,7 +4326,7 @@
                 <a:cs typeface="Leelawadee UI"/>
                 <a:ea typeface="Leelawadee UI"/>
               </a:rPr>
-              <a:t>บัญชีทดสอบ: admin / 11111111  ·  staff / 12345678  ·  customer / 12345678</a:t>
+              <a:t>บัญชีทดสอบ: admin / 12345678  ·  staff / 12345678  ·  customer / 12345678</a:t>
             </a:r>
           </a:p>
         </p:txBody>

</xml_diff>

<commit_message>
Update the test and file counts in the documents to match the code
The documents still claimed 247 tests across 9 modules and 10 migrations;
the tree now has 297 tests across 15 modules and 11 migrations.

Co-Authored-By: Claude Opus 4.8 (1M context) <noreply@anthropic.com>
</commit_message>
<xml_diff>
--- a/deliverables/ไฟล์นำเสนอ.pptx
+++ b/deliverables/ไฟล์นำเสนอ.pptx
@@ -3850,7 +3850,7 @@
                 <a:cs typeface="Leelawadee UI"/>
                 <a:ea typeface="Leelawadee UI"/>
               </a:rPr>
-              <a:t>•  ชุดทดสอบอัตโนมัติ 247 เคส แยก 9 โมดูล ผ่านทั้งหมด</a:t>
+              <a:t>•  ชุดทดสอบอัตโนมัติ 297 เคส แยก 15 โมดูล ผ่านทั้งหมด</a:t>
             </a:r>
           </a:p>
           <a:p>
@@ -3922,7 +3922,7 @@
                 <a:cs typeface="Leelawadee UI"/>
                 <a:ea typeface="Leelawadee UI"/>
               </a:rPr>
-              <a:t>คำสั่งรัน: python manage.py test  -&gt;  Ran 247 tests ... OK</a:t>
+              <a:t>คำสั่งรัน: python manage.py test  -&gt;  Ran 297 tests ... OK</a:t>
             </a:r>
           </a:p>
         </p:txBody>

</xml_diff>

<commit_message>
Refresh the submitted documents after the timezone fix
Test count moved to 314 across 17 modules.

Co-Authored-By: Claude Opus 4.8 (1M context) <noreply@anthropic.com>
</commit_message>
<xml_diff>
--- a/deliverables/ไฟล์นำเสนอ.pptx
+++ b/deliverables/ไฟล์นำเสนอ.pptx
@@ -3850,7 +3850,7 @@
                 <a:cs typeface="Leelawadee UI"/>
                 <a:ea typeface="Leelawadee UI"/>
               </a:rPr>
-              <a:t>•  ชุดทดสอบอัตโนมัติ 297 เคส แยก 15 โมดูล ผ่านทั้งหมด</a:t>
+              <a:t>•  ชุดทดสอบอัตโนมัติ 314 เคส แยก 17 โมดูล ผ่านทั้งหมด</a:t>
             </a:r>
           </a:p>
           <a:p>
@@ -3922,7 +3922,7 @@
                 <a:cs typeface="Leelawadee UI"/>
                 <a:ea typeface="Leelawadee UI"/>
               </a:rPr>
-              <a:t>คำสั่งรัน: python manage.py test  -&gt;  Ran 297 tests ... OK</a:t>
+              <a:t>คำสั่งรัน: python manage.py test  -&gt;  Ran 314 tests ... OK</a:t>
             </a:r>
           </a:p>
         </p:txBody>

</xml_diff>

<commit_message>
Update the documents to 329 tests across 19 modules
Co-Authored-By: Claude Opus 4.8 (1M context) <noreply@anthropic.com>
</commit_message>
<xml_diff>
--- a/deliverables/ไฟล์นำเสนอ.pptx
+++ b/deliverables/ไฟล์นำเสนอ.pptx
@@ -3850,7 +3850,7 @@
                 <a:cs typeface="Leelawadee UI"/>
                 <a:ea typeface="Leelawadee UI"/>
               </a:rPr>
-              <a:t>•  ชุดทดสอบอัตโนมัติ 314 เคส แยก 17 โมดูล ผ่านทั้งหมด</a:t>
+              <a:t>•  ชุดทดสอบอัตโนมัติ 329 เคส แยก 19 โมดูล ผ่านทั้งหมด</a:t>
             </a:r>
           </a:p>
           <a:p>
@@ -3922,7 +3922,7 @@
                 <a:cs typeface="Leelawadee UI"/>
                 <a:ea typeface="Leelawadee UI"/>
               </a:rPr>
-              <a:t>คำสั่งรัน: python manage.py test  -&gt;  Ran 314 tests ... OK</a:t>
+              <a:t>คำสั่งรัน: python manage.py test  -&gt;  Ran 329 tests ... OK</a:t>
             </a:r>
           </a:p>
         </p:txBody>

</xml_diff>

<commit_message>
Update the documents to 379 tests across 24 modules
Co-Authored-By: Claude Opus 4.8 (1M context) <noreply@anthropic.com>
</commit_message>
<xml_diff>
--- a/deliverables/ไฟล์นำเสนอ.pptx
+++ b/deliverables/ไฟล์นำเสนอ.pptx
@@ -3850,7 +3850,7 @@
                 <a:cs typeface="Leelawadee UI"/>
                 <a:ea typeface="Leelawadee UI"/>
               </a:rPr>
-              <a:t>•  ชุดทดสอบอัตโนมัติ 329 เคส แยก 19 โมดูล ผ่านทั้งหมด</a:t>
+              <a:t>•  ชุดทดสอบอัตโนมัติ 379 เคส แยก 24 โมดูล ผ่านทั้งหมด</a:t>
             </a:r>
           </a:p>
           <a:p>
@@ -3922,7 +3922,7 @@
                 <a:cs typeface="Leelawadee UI"/>
                 <a:ea typeface="Leelawadee UI"/>
               </a:rPr>
-              <a:t>คำสั่งรัน: python manage.py test  -&gt;  Ran 329 tests ... OK</a:t>
+              <a:t>คำสั่งรัน: python manage.py test  -&gt;  Ran 379 tests ... OK</a:t>
             </a:r>
           </a:p>
         </p:txBody>

</xml_diff>

<commit_message>
Refresh documents to 386 tests across 25 modules
</commit_message>
<xml_diff>
--- a/deliverables/ไฟล์นำเสนอ.pptx
+++ b/deliverables/ไฟล์นำเสนอ.pptx
@@ -3850,7 +3850,7 @@
                 <a:cs typeface="Leelawadee UI"/>
                 <a:ea typeface="Leelawadee UI"/>
               </a:rPr>
-              <a:t>•  ชุดทดสอบอัตโนมัติ 379 เคส แยก 24 โมดูล ผ่านทั้งหมด</a:t>
+              <a:t>•  ชุดทดสอบอัตโนมัติ 386 เคส แยก 25 โมดูล ผ่านทั้งหมด</a:t>
             </a:r>
           </a:p>
           <a:p>
@@ -3922,7 +3922,7 @@
                 <a:cs typeface="Leelawadee UI"/>
                 <a:ea typeface="Leelawadee UI"/>
               </a:rPr>
-              <a:t>คำสั่งรัน: python manage.py test  -&gt;  Ran 379 tests ... OK</a:t>
+              <a:t>คำสั่งรัน: python manage.py test  -&gt;  Ran 386 tests ... OK</a:t>
             </a:r>
           </a:p>
         </p:txBody>

</xml_diff>

<commit_message>
Update documents to match production: Neon, SECRET_KEY env, PDF export
</commit_message>
<xml_diff>
--- a/deliverables/ไฟล์นำเสนอ.pptx
+++ b/deliverables/ไฟล์นำเสนอ.pptx
@@ -4061,7 +4061,7 @@
                 <a:cs typeface="Leelawadee UI"/>
                 <a:ea typeface="Leelawadee UI"/>
               </a:rPr>
-              <a:t>•  ฐานข้อมูล SQLite บนดิสก์ชั่วคราว — ข้อมูลหายทุกครั้งที่ deploy ใหม่</a:t>
+              <a:t>•  ฐานข้อมูลการใช้งานจริงย้ายไป PostgreSQL (Neon) แล้ว — ข้อมูลคงอยู่ข้ามการ deploy</a:t>
             </a:r>
           </a:p>
           <a:p>
@@ -4079,7 +4079,7 @@
                 <a:cs typeface="Leelawadee UI"/>
                 <a:ea typeface="Leelawadee UI"/>
               </a:rPr>
-              <a:t>•  SECRET_KEY เป็นค่าสำรองในโค้ด ต้องตั้งเป็นตัวแปรสภาพแวดล้อม</a:t>
+              <a:t>•  SECRET_KEY ของการใช้งานจริงตั้งเป็นตัวแปรสภาพแวดล้อมแล้ว</a:t>
             </a:r>
           </a:p>
           <a:p>
@@ -4133,7 +4133,7 @@
                 <a:cs typeface="Leelawadee UI"/>
                 <a:ea typeface="Leelawadee UI"/>
               </a:rPr>
-              <a:t>•  ปุ่มส่งออก PDF บนแดชบอร์ดยังไม่ได้เชื่อมต่อ</a:t>
+              <a:t>•  ปุ่มส่งออก PDF บนแดชบอร์ดเชื่อมต่อแล้วผ่าน window.print()</a:t>
             </a:r>
           </a:p>
         </p:txBody>
@@ -4941,7 +4941,7 @@
                 <a:cs typeface="Leelawadee UI"/>
                 <a:ea typeface="Leelawadee UI"/>
               </a:rPr>
-              <a:t>•  ฐานข้อมูล SQLite รองรับการสลับเป็นฐานข้อมูลภายนอกผ่าน DATABASE_URL</a:t>
+              <a:t>•  ฐานข้อมูล PostgreSQL (Neon) ในการใช้งานจริง SQLite สำหรับพัฒนาในเครื่อง</a:t>
             </a:r>
           </a:p>
           <a:p>

</xml_diff>